<commit_message>
Order quiz review answers to match their questions
</commit_message>
<xml_diff>
--- a/public/presentations/CS211_Recitation_6.pptx
+++ b/public/presentations/CS211_Recitation_6.pptx
@@ -2,39 +2,39 @@
 <file path=ppt/presentation.xml><?xml version="1.0" encoding="utf-8"?>
 <p:presentation xmlns:p="http://schemas.openxmlformats.org/presentationml/2006/main" embedTrueTypeFonts="1" saveSubsetFonts="0">
   <p:sldMasterIdLst>
-    <p:sldMasterId xmlns:r="http://schemas.openxmlformats.org/officeDocument/2006/relationships" id="2147483648" r:id="Rce37a3c3114c4fbb"/>
+    <p:sldMasterId xmlns:r="http://schemas.openxmlformats.org/officeDocument/2006/relationships" id="2147483648" r:id="Rc546562754c84fab"/>
   </p:sldMasterIdLst>
   <p:notesMasterIdLst>
-    <p:notesMasterId xmlns:r="http://schemas.openxmlformats.org/officeDocument/2006/relationships" r:id="R5c35e858747f439c"/>
+    <p:notesMasterId xmlns:r="http://schemas.openxmlformats.org/officeDocument/2006/relationships" r:id="R18c94962a3424da1"/>
   </p:notesMasterIdLst>
   <p:sldIdLst>
-    <p:sldId xmlns:r="http://schemas.openxmlformats.org/officeDocument/2006/relationships" id="256" r:id="Rc0b04962c1d14109"/>
-    <p:sldId xmlns:r="http://schemas.openxmlformats.org/officeDocument/2006/relationships" id="257" r:id="Rd5598d8b35224914"/>
-    <p:sldId xmlns:r="http://schemas.openxmlformats.org/officeDocument/2006/relationships" id="258" r:id="R0001a3d091b941ea"/>
-    <p:sldId xmlns:r="http://schemas.openxmlformats.org/officeDocument/2006/relationships" id="259" r:id="R061d007f5163488a"/>
-    <p:sldId xmlns:r="http://schemas.openxmlformats.org/officeDocument/2006/relationships" id="260" r:id="R093fe9de0fa04d5b"/>
-    <p:sldId xmlns:r="http://schemas.openxmlformats.org/officeDocument/2006/relationships" id="261" r:id="R4405dd60f6e64fe1"/>
-    <p:sldId xmlns:r="http://schemas.openxmlformats.org/officeDocument/2006/relationships" id="262" r:id="R2d46f393895b47f7"/>
-    <p:sldId xmlns:r="http://schemas.openxmlformats.org/officeDocument/2006/relationships" id="263" r:id="Rb45b38a895b34685"/>
-    <p:sldId xmlns:r="http://schemas.openxmlformats.org/officeDocument/2006/relationships" id="264" r:id="Rc26d04a3c4134368"/>
-    <p:sldId xmlns:r="http://schemas.openxmlformats.org/officeDocument/2006/relationships" id="265" r:id="R527aeb9a87c044dd"/>
-    <p:sldId xmlns:r="http://schemas.openxmlformats.org/officeDocument/2006/relationships" id="266" r:id="Ra5959446f9ae4689"/>
-    <p:sldId xmlns:r="http://schemas.openxmlformats.org/officeDocument/2006/relationships" id="267" r:id="R6fd01f14fd4d48e0"/>
-    <p:sldId xmlns:r="http://schemas.openxmlformats.org/officeDocument/2006/relationships" id="268" r:id="R02183aec252d477a"/>
-    <p:sldId xmlns:r="http://schemas.openxmlformats.org/officeDocument/2006/relationships" id="269" r:id="R54be0667eeb44c19"/>
-    <p:sldId xmlns:r="http://schemas.openxmlformats.org/officeDocument/2006/relationships" id="270" r:id="R27efccb5765d4072"/>
-    <p:sldId xmlns:r="http://schemas.openxmlformats.org/officeDocument/2006/relationships" id="271" r:id="R760e4731d18341b3"/>
-    <p:sldId xmlns:r="http://schemas.openxmlformats.org/officeDocument/2006/relationships" id="272" r:id="Reeac349dda054a70"/>
+    <p:sldId xmlns:r="http://schemas.openxmlformats.org/officeDocument/2006/relationships" id="256" r:id="R110869d41b21419b"/>
+    <p:sldId xmlns:r="http://schemas.openxmlformats.org/officeDocument/2006/relationships" id="257" r:id="R3d01d33dd3914642"/>
+    <p:sldId xmlns:r="http://schemas.openxmlformats.org/officeDocument/2006/relationships" id="258" r:id="R6869c86500834ebe"/>
+    <p:sldId xmlns:r="http://schemas.openxmlformats.org/officeDocument/2006/relationships" id="259" r:id="Rbe860b6dc89845a2"/>
+    <p:sldId xmlns:r="http://schemas.openxmlformats.org/officeDocument/2006/relationships" id="260" r:id="Rf11b65376f174638"/>
+    <p:sldId xmlns:r="http://schemas.openxmlformats.org/officeDocument/2006/relationships" id="261" r:id="R5a954e3fa19b4a74"/>
+    <p:sldId xmlns:r="http://schemas.openxmlformats.org/officeDocument/2006/relationships" id="262" r:id="R9b659ccf9ed94c1c"/>
+    <p:sldId xmlns:r="http://schemas.openxmlformats.org/officeDocument/2006/relationships" id="263" r:id="Rb76f5cce82184a70"/>
+    <p:sldId xmlns:r="http://schemas.openxmlformats.org/officeDocument/2006/relationships" id="264" r:id="R3297c3245b304110"/>
+    <p:sldId xmlns:r="http://schemas.openxmlformats.org/officeDocument/2006/relationships" id="265" r:id="R13f28eab663e499a"/>
+    <p:sldId xmlns:r="http://schemas.openxmlformats.org/officeDocument/2006/relationships" id="266" r:id="R6f50a71239d341cf"/>
+    <p:sldId xmlns:r="http://schemas.openxmlformats.org/officeDocument/2006/relationships" id="267" r:id="Reefa3f5b44cb4239"/>
+    <p:sldId xmlns:r="http://schemas.openxmlformats.org/officeDocument/2006/relationships" id="268" r:id="Rd37e706a9aec496d"/>
+    <p:sldId xmlns:r="http://schemas.openxmlformats.org/officeDocument/2006/relationships" id="269" r:id="Rfaa40ca614cd44ef"/>
+    <p:sldId xmlns:r="http://schemas.openxmlformats.org/officeDocument/2006/relationships" id="270" r:id="R471baf6deba64591"/>
+    <p:sldId xmlns:r="http://schemas.openxmlformats.org/officeDocument/2006/relationships" id="271" r:id="Rc7e3907cafd54fce"/>
+    <p:sldId xmlns:r="http://schemas.openxmlformats.org/officeDocument/2006/relationships" id="272" r:id="R4a5f4798a59f4262"/>
   </p:sldIdLst>
   <p:sldSz cx="12192000" cy="6858000"/>
   <p:notesSz cx="6858000" cy="9144000"/>
   <p:embeddedFontLst>
     <p:embeddedFont>
       <p:font typeface="OpenAI Sans"/>
-      <p:regular xmlns:r="http://schemas.openxmlformats.org/officeDocument/2006/relationships" r:id="Ref6c7c355c124c65"/>
-      <p:bold xmlns:r="http://schemas.openxmlformats.org/officeDocument/2006/relationships" r:id="R159c817443a34e57"/>
-      <p:italic xmlns:r="http://schemas.openxmlformats.org/officeDocument/2006/relationships" r:id="R0c15ccd6159846fe"/>
-      <p:boldItalic xmlns:r="http://schemas.openxmlformats.org/officeDocument/2006/relationships" r:id="R35b3b56cd8184365"/>
+      <p:regular xmlns:r="http://schemas.openxmlformats.org/officeDocument/2006/relationships" r:id="R417b4eba6db447c3"/>
+      <p:bold xmlns:r="http://schemas.openxmlformats.org/officeDocument/2006/relationships" r:id="Re4d1668761e9423e"/>
+      <p:italic xmlns:r="http://schemas.openxmlformats.org/officeDocument/2006/relationships" r:id="R3dee533c0dc64ec6"/>
+      <p:boldItalic xmlns:r="http://schemas.openxmlformats.org/officeDocument/2006/relationships" r:id="R28372c5e0a8949ec"/>
     </p:embeddedFont>
   </p:embeddedFontLst>
   <p:defaultTextStyle>
@@ -636,7 +636,67 @@
               <a:buNone/>
             </a:pPr>
             <a:r>
-              <a:t>Answer: E = 126, so the actual exponent is −1. The set fraction bits contribute 1/2 + 1/8 = 0.625. The complete significand is 1.625, giving 2^(−1) × 1.625 = 0.8125. The final bit pattern is 0x3F500000.</a:t>
+              <a:t>Answer: 1. Stored exponent E = 126, so the actual exponent is 126 − 127 = −1.</a:t>
+            </a:r>
+            <a:endParaRPr/>
+          </a:p>
+          <a:p xmlns:a="http://schemas.openxmlformats.org/drawingml/2006/main">
+            <a:pPr marL="0" lvl="0" indent="0" algn="l">
+              <a:spcBef>
+                <a:spcPts val="0"/>
+              </a:spcBef>
+              <a:spcAft>
+                <a:spcPts val="0"/>
+              </a:spcAft>
+              <a:buNone/>
+            </a:pPr>
+            <a:r>
+              <a:t/>
+            </a:r>
+            <a:endParaRPr/>
+          </a:p>
+          <a:p xmlns:a="http://schemas.openxmlformats.org/drawingml/2006/main">
+            <a:pPr marL="0" lvl="0" indent="0" algn="l">
+              <a:spcBef>
+                <a:spcPts val="0"/>
+              </a:spcBef>
+              <a:spcAft>
+                <a:spcPts val="0"/>
+              </a:spcAft>
+              <a:buNone/>
+            </a:pPr>
+            <a:r>
+              <a:t>2. Fraction weights: bits 22 and 20 contribute 1/2 + 1/8 = 0.625. Restore the implied 1 to get a significand of 1.625.</a:t>
+            </a:r>
+            <a:endParaRPr/>
+          </a:p>
+          <a:p xmlns:a="http://schemas.openxmlformats.org/drawingml/2006/main">
+            <a:pPr marL="0" lvl="0" indent="0" algn="l">
+              <a:spcBef>
+                <a:spcPts val="0"/>
+              </a:spcBef>
+              <a:spcAft>
+                <a:spcPts val="0"/>
+              </a:spcAft>
+              <a:buNone/>
+            </a:pPr>
+            <a:r>
+              <a:t/>
+            </a:r>
+            <a:endParaRPr/>
+          </a:p>
+          <a:p xmlns:a="http://schemas.openxmlformats.org/drawingml/2006/main">
+            <a:pPr marL="0" lvl="0" indent="0" algn="l">
+              <a:spcBef>
+                <a:spcPts val="0"/>
+              </a:spcBef>
+              <a:spcAft>
+                <a:spcPts val="0"/>
+              </a:spcAft>
+              <a:buNone/>
+            </a:pPr>
+            <a:r>
+              <a:t>3. Decimal value = 2^(−1) × 1.625 = 0.8125. The final bit pattern is 0x3F500000.</a:t>
             </a:r>
             <a:endParaRPr/>
           </a:p>
@@ -746,7 +806,127 @@
               <a:buNone/>
             </a:pPr>
             <a:r>
-              <a:t>Answer: 6.5 = 110.1₂ = 1.101₂ × 2². For −6.5, sign = 1; stored exponent = 2 + 127 = 129 = 10000001₂; fraction = 101 followed by 20 zeros. The FP32 bit pattern is 0xC0D00000.</a:t>
+              <a:t>Answer: 1. Binary magnitude: 6.5 = 110.1₂.</a:t>
+            </a:r>
+            <a:endParaRPr/>
+          </a:p>
+          <a:p xmlns:a="http://schemas.openxmlformats.org/drawingml/2006/main">
+            <a:pPr marL="0" lvl="0" indent="0" algn="l">
+              <a:spcBef>
+                <a:spcPts val="0"/>
+              </a:spcBef>
+              <a:spcAft>
+                <a:spcPts val="0"/>
+              </a:spcAft>
+              <a:buNone/>
+            </a:pPr>
+            <a:r>
+              <a:t/>
+            </a:r>
+            <a:endParaRPr/>
+          </a:p>
+          <a:p xmlns:a="http://schemas.openxmlformats.org/drawingml/2006/main">
+            <a:pPr marL="0" lvl="0" indent="0" algn="l">
+              <a:spcBef>
+                <a:spcPts val="0"/>
+              </a:spcBef>
+              <a:spcAft>
+                <a:spcPts val="0"/>
+              </a:spcAft>
+              <a:buNone/>
+            </a:pPr>
+            <a:r>
+              <a:t>2. Normalized magnitude: 1.101₂ × 2².</a:t>
+            </a:r>
+            <a:endParaRPr/>
+          </a:p>
+          <a:p xmlns:a="http://schemas.openxmlformats.org/drawingml/2006/main">
+            <a:pPr marL="0" lvl="0" indent="0" algn="l">
+              <a:spcBef>
+                <a:spcPts val="0"/>
+              </a:spcBef>
+              <a:spcAft>
+                <a:spcPts val="0"/>
+              </a:spcAft>
+              <a:buNone/>
+            </a:pPr>
+            <a:r>
+              <a:t/>
+            </a:r>
+            <a:endParaRPr/>
+          </a:p>
+          <a:p xmlns:a="http://schemas.openxmlformats.org/drawingml/2006/main">
+            <a:pPr marL="0" lvl="0" indent="0" algn="l">
+              <a:spcBef>
+                <a:spcPts val="0"/>
+              </a:spcBef>
+              <a:spcAft>
+                <a:spcPts val="0"/>
+              </a:spcAft>
+              <a:buNone/>
+            </a:pPr>
+            <a:r>
+              <a:t>3. Sign bit = 1 because the requested value is negative.</a:t>
+            </a:r>
+            <a:endParaRPr/>
+          </a:p>
+          <a:p xmlns:a="http://schemas.openxmlformats.org/drawingml/2006/main">
+            <a:pPr marL="0" lvl="0" indent="0" algn="l">
+              <a:spcBef>
+                <a:spcPts val="0"/>
+              </a:spcBef>
+              <a:spcAft>
+                <a:spcPts val="0"/>
+              </a:spcAft>
+              <a:buNone/>
+            </a:pPr>
+            <a:r>
+              <a:t/>
+            </a:r>
+            <a:endParaRPr/>
+          </a:p>
+          <a:p xmlns:a="http://schemas.openxmlformats.org/drawingml/2006/main">
+            <a:pPr marL="0" lvl="0" indent="0" algn="l">
+              <a:spcBef>
+                <a:spcPts val="0"/>
+              </a:spcBef>
+              <a:spcAft>
+                <a:spcPts val="0"/>
+              </a:spcAft>
+              <a:buNone/>
+            </a:pPr>
+            <a:r>
+              <a:t>4. Stored exponent = 2 + 127 = 129 = 10000001₂.</a:t>
+            </a:r>
+            <a:endParaRPr/>
+          </a:p>
+          <a:p xmlns:a="http://schemas.openxmlformats.org/drawingml/2006/main">
+            <a:pPr marL="0" lvl="0" indent="0" algn="l">
+              <a:spcBef>
+                <a:spcPts val="0"/>
+              </a:spcBef>
+              <a:spcAft>
+                <a:spcPts val="0"/>
+              </a:spcAft>
+              <a:buNone/>
+            </a:pPr>
+            <a:r>
+              <a:t/>
+            </a:r>
+            <a:endParaRPr/>
+          </a:p>
+          <a:p xmlns:a="http://schemas.openxmlformats.org/drawingml/2006/main">
+            <a:pPr marL="0" lvl="0" indent="0" algn="l">
+              <a:spcBef>
+                <a:spcPts val="0"/>
+              </a:spcBef>
+              <a:spcAft>
+                <a:spcPts val="0"/>
+              </a:spcAft>
+              <a:buNone/>
+            </a:pPr>
+            <a:r>
+              <a:t>5. Fraction = 101 followed by 20 zeros. The complete FP32 bit pattern is 0xC0D00000.</a:t>
             </a:r>
             <a:endParaRPr/>
           </a:p>
@@ -1016,7 +1196,37 @@
               <a:buNone/>
             </a:pPr>
             <a:r>
-              <a:t>Answer: mulss produces 2.5 × 4.0 = 10.0. addss produces 10.0 + 4.0 = 14.0. cvtss2sd converts the low scalar value to a double, still 14.0. C promotes float arguments to double for variadic functions such as printf; %f expects that promoted value.</a:t>
+              <a:t>Answer: 1. Values after each instruction: mulss gives 10.0; addss gives 14.0; cvtss2sd converts that low scalar value to a double, still 14.0.</a:t>
+            </a:r>
+            <a:endParaRPr/>
+          </a:p>
+          <a:p xmlns:a="http://schemas.openxmlformats.org/drawingml/2006/main">
+            <a:pPr marL="0" lvl="0" indent="0" algn="l">
+              <a:spcBef>
+                <a:spcPts val="0"/>
+              </a:spcBef>
+              <a:spcAft>
+                <a:spcPts val="0"/>
+              </a:spcAft>
+              <a:buNone/>
+            </a:pPr>
+            <a:r>
+              <a:t/>
+            </a:r>
+            <a:endParaRPr/>
+          </a:p>
+          <a:p xmlns:a="http://schemas.openxmlformats.org/drawingml/2006/main">
+            <a:pPr marL="0" lvl="0" indent="0" algn="l">
+              <a:spcBef>
+                <a:spcPts val="0"/>
+              </a:spcBef>
+              <a:spcAft>
+                <a:spcPts val="0"/>
+              </a:spcAft>
+              <a:buNone/>
+            </a:pPr>
+            <a:r>
+              <a:t>2. Why convert before printf? C promotes float arguments to double for variadic functions such as printf; %f expects that promoted value.</a:t>
             </a:r>
             <a:endParaRPr/>
           </a:p>
@@ -1126,7 +1336,37 @@
               <a:buNone/>
             </a:pPr>
             <a:r>
-              <a:t>Answer: No. 40 × 2 KiB = 80 KiB, which exceeds 64 KiB. At most 32 frames fit in this simplified model. Real frames have other costs, and stack limits depend on the environment. The stack need not literally collide with the heap to overflow.</a:t>
+              <a:t>Answer: 1. Required space: 40 × 2 KiB = 80 KiB.</a:t>
+            </a:r>
+            <a:endParaRPr/>
+          </a:p>
+          <a:p xmlns:a="http://schemas.openxmlformats.org/drawingml/2006/main">
+            <a:pPr marL="0" lvl="0" indent="0" algn="l">
+              <a:spcBef>
+                <a:spcPts val="0"/>
+              </a:spcBef>
+              <a:spcAft>
+                <a:spcPts val="0"/>
+              </a:spcAft>
+              <a:buNone/>
+            </a:pPr>
+            <a:r>
+              <a:t/>
+            </a:r>
+            <a:endParaRPr/>
+          </a:p>
+          <a:p xmlns:a="http://schemas.openxmlformats.org/drawingml/2006/main">
+            <a:pPr marL="0" lvl="0" indent="0" algn="l">
+              <a:spcBef>
+                <a:spcPts val="0"/>
+              </a:spcBef>
+              <a:spcAft>
+                <a:spcPts val="0"/>
+              </a:spcAft>
+              <a:buNone/>
+            </a:pPr>
+            <a:r>
+              <a:t>2. Can 40 active calls fit? No. 80 KiB exceeds the 64 KiB budget; at most 32 frames fit in this simplified model. Real frames have other costs, and stack limits depend on the environment. The stack need not literally collide with the heap to overflow.</a:t>
             </a:r>
             <a:endParaRPr/>
           </a:p>
@@ -1236,7 +1476,97 @@
               <a:buNone/>
             </a:pPr>
             <a:r>
-              <a:t>Answer: name has 4 bytes, with valid indices 0–3. The terminator at name[4] is out of bounds. A 4-byte buffer holds at most 3 ordinary string characters plus a null terminator. A write past a stack buffer can corrupt adjacent data or saved call state, but the exact effect and whether it crashes are not guaranteed.</a:t>
+              <a:t>Answer: 1. Capacity: name has 4 bytes, so it holds at most 3 ordinary string characters plus a null terminator.</a:t>
+            </a:r>
+            <a:endParaRPr/>
+          </a:p>
+          <a:p xmlns:a="http://schemas.openxmlformats.org/drawingml/2006/main">
+            <a:pPr marL="0" lvl="0" indent="0" algn="l">
+              <a:spcBef>
+                <a:spcPts val="0"/>
+              </a:spcBef>
+              <a:spcAft>
+                <a:spcPts val="0"/>
+              </a:spcAft>
+              <a:buNone/>
+            </a:pPr>
+            <a:r>
+              <a:t/>
+            </a:r>
+            <a:endParaRPr/>
+          </a:p>
+          <a:p xmlns:a="http://schemas.openxmlformats.org/drawingml/2006/main">
+            <a:pPr marL="0" lvl="0" indent="0" algn="l">
+              <a:spcBef>
+                <a:spcPts val="0"/>
+              </a:spcBef>
+              <a:spcAft>
+                <a:spcPts val="0"/>
+              </a:spcAft>
+              <a:buNone/>
+            </a:pPr>
+            <a:r>
+              <a:t>2. Invalid write: name[4] is out of bounds; valid indices are 0–3.</a:t>
+            </a:r>
+            <a:endParaRPr/>
+          </a:p>
+          <a:p xmlns:a="http://schemas.openxmlformats.org/drawingml/2006/main">
+            <a:pPr marL="0" lvl="0" indent="0" algn="l">
+              <a:spcBef>
+                <a:spcPts val="0"/>
+              </a:spcBef>
+              <a:spcAft>
+                <a:spcPts val="0"/>
+              </a:spcAft>
+              <a:buNone/>
+            </a:pPr>
+            <a:r>
+              <a:t/>
+            </a:r>
+            <a:endParaRPr/>
+          </a:p>
+          <a:p xmlns:a="http://schemas.openxmlformats.org/drawingml/2006/main">
+            <a:pPr marL="0" lvl="0" indent="0" algn="l">
+              <a:spcBef>
+                <a:spcPts val="0"/>
+              </a:spcBef>
+              <a:spcAft>
+                <a:spcPts val="0"/>
+              </a:spcAft>
+              <a:buNone/>
+            </a:pPr>
+            <a:r>
+              <a:t>3. Could it affect nearby stack data? Yes. A write past a stack buffer can corrupt adjacent data or saved call state.</a:t>
+            </a:r>
+            <a:endParaRPr/>
+          </a:p>
+          <a:p xmlns:a="http://schemas.openxmlformats.org/drawingml/2006/main">
+            <a:pPr marL="0" lvl="0" indent="0" algn="l">
+              <a:spcBef>
+                <a:spcPts val="0"/>
+              </a:spcBef>
+              <a:spcAft>
+                <a:spcPts val="0"/>
+              </a:spcAft>
+              <a:buNone/>
+            </a:pPr>
+            <a:r>
+              <a:t/>
+            </a:r>
+            <a:endParaRPr/>
+          </a:p>
+          <a:p xmlns:a="http://schemas.openxmlformats.org/drawingml/2006/main">
+            <a:pPr marL="0" lvl="0" indent="0" algn="l">
+              <a:spcBef>
+                <a:spcPts val="0"/>
+              </a:spcBef>
+              <a:spcAft>
+                <a:spcPts val="0"/>
+              </a:spcAft>
+              <a:buNone/>
+            </a:pPr>
+            <a:r>
+              <a:t>4. Is a crash guaranteed? No. The write is undefined behavior; the exact effect is not guaranteed.</a:t>
             </a:r>
             <a:endParaRPr/>
           </a:p>
@@ -1346,7 +1676,97 @@
               <a:buNone/>
             </a:pPr>
             <a:r>
-              <a:t>Answer: A: a canary is checked for unexpected modification and can detect some stack overwrites. B: ASLR randomizes relevant address-space locations. C: NX prevents instruction execution from pages marked non-executable. None makes an invalid write valid, and none guarantees protection from every memory error or attack.</a:t>
+              <a:t>Answer: 1. Detects some stack corruption: A, the stack canary. It is checked for unexpected modification.</a:t>
+            </a:r>
+            <a:endParaRPr/>
+          </a:p>
+          <a:p xmlns:a="http://schemas.openxmlformats.org/drawingml/2006/main">
+            <a:pPr marL="0" lvl="0" indent="0" algn="l">
+              <a:spcBef>
+                <a:spcPts val="0"/>
+              </a:spcBef>
+              <a:spcAft>
+                <a:spcPts val="0"/>
+              </a:spcAft>
+              <a:buNone/>
+            </a:pPr>
+            <a:r>
+              <a:t/>
+            </a:r>
+            <a:endParaRPr/>
+          </a:p>
+          <a:p xmlns:a="http://schemas.openxmlformats.org/drawingml/2006/main">
+            <a:pPr marL="0" lvl="0" indent="0" algn="l">
+              <a:spcBef>
+                <a:spcPts val="0"/>
+              </a:spcBef>
+              <a:spcAft>
+                <a:spcPts val="0"/>
+              </a:spcAft>
+              <a:buNone/>
+            </a:pPr>
+            <a:r>
+              <a:t>2. Makes addresses less predictable: B, ASLR. It randomizes relevant address-space locations.</a:t>
+            </a:r>
+            <a:endParaRPr/>
+          </a:p>
+          <a:p xmlns:a="http://schemas.openxmlformats.org/drawingml/2006/main">
+            <a:pPr marL="0" lvl="0" indent="0" algn="l">
+              <a:spcBef>
+                <a:spcPts val="0"/>
+              </a:spcBef>
+              <a:spcAft>
+                <a:spcPts val="0"/>
+              </a:spcAft>
+              <a:buNone/>
+            </a:pPr>
+            <a:r>
+              <a:t/>
+            </a:r>
+            <a:endParaRPr/>
+          </a:p>
+          <a:p xmlns:a="http://schemas.openxmlformats.org/drawingml/2006/main">
+            <a:pPr marL="0" lvl="0" indent="0" algn="l">
+              <a:spcBef>
+                <a:spcPts val="0"/>
+              </a:spcBef>
+              <a:spcAft>
+                <a:spcPts val="0"/>
+              </a:spcAft>
+              <a:buNone/>
+            </a:pPr>
+            <a:r>
+              <a:t>3. Prevents execution from data pages: C, NX. It blocks instruction execution from pages marked non-executable.</a:t>
+            </a:r>
+            <a:endParaRPr/>
+          </a:p>
+          <a:p xmlns:a="http://schemas.openxmlformats.org/drawingml/2006/main">
+            <a:pPr marL="0" lvl="0" indent="0" algn="l">
+              <a:spcBef>
+                <a:spcPts val="0"/>
+              </a:spcBef>
+              <a:spcAft>
+                <a:spcPts val="0"/>
+              </a:spcAft>
+              <a:buNone/>
+            </a:pPr>
+            <a:r>
+              <a:t/>
+            </a:r>
+            <a:endParaRPr/>
+          </a:p>
+          <a:p xmlns:a="http://schemas.openxmlformats.org/drawingml/2006/main">
+            <a:pPr marL="0" lvl="0" indent="0" algn="l">
+              <a:spcBef>
+                <a:spcPts val="0"/>
+              </a:spcBef>
+              <a:spcAft>
+                <a:spcPts val="0"/>
+              </a:spcAft>
+              <a:buNone/>
+            </a:pPr>
+            <a:r>
+              <a:t>4. Does any mechanism make an out-of-bounds write valid? No. None fixes the invalid write or guarantees protection from every memory error or attack.</a:t>
             </a:r>
             <a:endParaRPr/>
           </a:p>
@@ -1536,7 +1956,67 @@
               <a:buNone/>
             </a:pPr>
             <a:r>
-              <a:t>Answer: No. scores has automatic storage duration; its lifetime ends when the function returns. Reading p[0] afterward is invalid. A successful malloc allocation remains alive until it is freed, so its pointer can be returned. The caller must take responsibility for freeing it.</a:t>
+              <a:t>Answer: 1. What is wrong with the function? It returns a pointer to the local array scores, whose lifetime ends when make_scores returns. Returning its address does not keep the array alive.</a:t>
+            </a:r>
+            <a:endParaRPr/>
+          </a:p>
+          <a:p xmlns:a="http://schemas.openxmlformats.org/drawingml/2006/main">
+            <a:pPr marL="0" lvl="0" indent="0" algn="l">
+              <a:spcBef>
+                <a:spcPts val="0"/>
+              </a:spcBef>
+              <a:spcAft>
+                <a:spcPts val="0"/>
+              </a:spcAft>
+              <a:buNone/>
+            </a:pPr>
+            <a:r>
+              <a:t/>
+            </a:r>
+            <a:endParaRPr/>
+          </a:p>
+          <a:p xmlns:a="http://schemas.openxmlformats.org/drawingml/2006/main">
+            <a:pPr marL="0" lvl="0" indent="0" algn="l">
+              <a:spcBef>
+                <a:spcPts val="0"/>
+              </a:spcBef>
+              <a:spcAft>
+                <a:spcPts val="0"/>
+              </a:spcAft>
+              <a:buNone/>
+            </a:pPr>
+            <a:r>
+              <a:t>2. Would malloc have the same lifetime problem? No. A successful malloc allocation remains alive until it is freed, so its pointer can be returned. The caller must take responsibility for freeing it.</a:t>
+            </a:r>
+            <a:endParaRPr/>
+          </a:p>
+          <a:p xmlns:a="http://schemas.openxmlformats.org/drawingml/2006/main">
+            <a:pPr marL="0" lvl="0" indent="0" algn="l">
+              <a:spcBef>
+                <a:spcPts val="0"/>
+              </a:spcBef>
+              <a:spcAft>
+                <a:spcPts val="0"/>
+              </a:spcAft>
+              <a:buNone/>
+            </a:pPr>
+            <a:r>
+              <a:t/>
+            </a:r>
+            <a:endParaRPr/>
+          </a:p>
+          <a:p xmlns:a="http://schemas.openxmlformats.org/drawingml/2006/main">
+            <a:pPr marL="0" lvl="0" indent="0" algn="l">
+              <a:spcBef>
+                <a:spcPts val="0"/>
+              </a:spcBef>
+              <a:spcAft>
+                <a:spcPts val="0"/>
+              </a:spcAft>
+              <a:buNone/>
+            </a:pPr>
+            <a:r>
+              <a:t>3. Can we safely read p[0] in the shown code? No. The local scores array no longer exists after the function returns.</a:t>
             </a:r>
             <a:endParaRPr/>
           </a:p>
@@ -1726,7 +2206,97 @@
               <a:buNone/>
             </a:pPr>
             <a:r>
-              <a:t>Answer: sizeof p = 8 bytes. sizeof *p = 8 bytes because *p has type double. The allocation requests 6 × 8 = 48 bytes, excluding allocator overhead. free(p) releases the allocated block; p itself remains in scope and must not be used to access the freed memory.</a:t>
+              <a:t>Answer: 1. sizeof p = 8 bytes: the size of the pointer.</a:t>
+            </a:r>
+            <a:endParaRPr/>
+          </a:p>
+          <a:p xmlns:a="http://schemas.openxmlformats.org/drawingml/2006/main">
+            <a:pPr marL="0" lvl="0" indent="0" algn="l">
+              <a:spcBef>
+                <a:spcPts val="0"/>
+              </a:spcBef>
+              <a:spcAft>
+                <a:spcPts val="0"/>
+              </a:spcAft>
+              <a:buNone/>
+            </a:pPr>
+            <a:r>
+              <a:t/>
+            </a:r>
+            <a:endParaRPr/>
+          </a:p>
+          <a:p xmlns:a="http://schemas.openxmlformats.org/drawingml/2006/main">
+            <a:pPr marL="0" lvl="0" indent="0" algn="l">
+              <a:spcBef>
+                <a:spcPts val="0"/>
+              </a:spcBef>
+              <a:spcAft>
+                <a:spcPts val="0"/>
+              </a:spcAft>
+              <a:buNone/>
+            </a:pPr>
+            <a:r>
+              <a:t>2. sizeof *p = 8 bytes: the size of a double.</a:t>
+            </a:r>
+            <a:endParaRPr/>
+          </a:p>
+          <a:p xmlns:a="http://schemas.openxmlformats.org/drawingml/2006/main">
+            <a:pPr marL="0" lvl="0" indent="0" algn="l">
+              <a:spcBef>
+                <a:spcPts val="0"/>
+              </a:spcBef>
+              <a:spcAft>
+                <a:spcPts val="0"/>
+              </a:spcAft>
+              <a:buNone/>
+            </a:pPr>
+            <a:r>
+              <a:t/>
+            </a:r>
+            <a:endParaRPr/>
+          </a:p>
+          <a:p xmlns:a="http://schemas.openxmlformats.org/drawingml/2006/main">
+            <a:pPr marL="0" lvl="0" indent="0" algn="l">
+              <a:spcBef>
+                <a:spcPts val="0"/>
+              </a:spcBef>
+              <a:spcAft>
+                <a:spcPts val="0"/>
+              </a:spcAft>
+              <a:buNone/>
+            </a:pPr>
+            <a:r>
+              <a:t>3. Requested allocation size = 6 × 8 = 48 bytes, excluding allocator overhead.</a:t>
+            </a:r>
+            <a:endParaRPr/>
+          </a:p>
+          <a:p xmlns:a="http://schemas.openxmlformats.org/drawingml/2006/main">
+            <a:pPr marL="0" lvl="0" indent="0" algn="l">
+              <a:spcBef>
+                <a:spcPts val="0"/>
+              </a:spcBef>
+              <a:spcAft>
+                <a:spcPts val="0"/>
+              </a:spcAft>
+              <a:buNone/>
+            </a:pPr>
+            <a:r>
+              <a:t/>
+            </a:r>
+            <a:endParaRPr/>
+          </a:p>
+          <a:p xmlns:a="http://schemas.openxmlformats.org/drawingml/2006/main">
+            <a:pPr marL="0" lvl="0" indent="0" algn="l">
+              <a:spcBef>
+                <a:spcPts val="0"/>
+              </a:spcBef>
+              <a:spcAft>
+                <a:spcPts val="0"/>
+              </a:spcAft>
+              <a:buNone/>
+            </a:pPr>
+            <a:r>
+              <a:t>4. Does free(p) remove p? No. It releases the allocated block; the local pointer variable remains in scope and must not be used to access the freed memory.</a:t>
             </a:r>
             <a:endParaRPr/>
           </a:p>
@@ -1916,7 +2486,67 @@
               <a:buNone/>
             </a:pPr>
             <a:r>
-              <a:t>Answer: tag starts at byte 0; count at byte 4; ready at byte 8. Bytes 1–3 are internal padding and bytes 9–11 are tail padding, so the struct is 12 bytes with alignment 4. As a union, every member starts at byte 0 and the size is 4 bytes under these assumptions.</a:t>
+              <a:t>Answer: 1. Member offsets: tag starts at byte 0, count at byte 4, and ready at byte 8.</a:t>
+            </a:r>
+            <a:endParaRPr/>
+          </a:p>
+          <a:p xmlns:a="http://schemas.openxmlformats.org/drawingml/2006/main">
+            <a:pPr marL="0" lvl="0" indent="0" algn="l">
+              <a:spcBef>
+                <a:spcPts val="0"/>
+              </a:spcBef>
+              <a:spcAft>
+                <a:spcPts val="0"/>
+              </a:spcAft>
+              <a:buNone/>
+            </a:pPr>
+            <a:r>
+              <a:t/>
+            </a:r>
+            <a:endParaRPr/>
+          </a:p>
+          <a:p xmlns:a="http://schemas.openxmlformats.org/drawingml/2006/main">
+            <a:pPr marL="0" lvl="0" indent="0" algn="l">
+              <a:spcBef>
+                <a:spcPts val="0"/>
+              </a:spcBef>
+              <a:spcAft>
+                <a:spcPts val="0"/>
+              </a:spcAft>
+              <a:buNone/>
+            </a:pPr>
+            <a:r>
+              <a:t>2. sizeof(struct Record) = 12 bytes, with alignment 4. Bytes 1–3 are internal padding; bytes 9–11 are tail padding.</a:t>
+            </a:r>
+            <a:endParaRPr/>
+          </a:p>
+          <a:p xmlns:a="http://schemas.openxmlformats.org/drawingml/2006/main">
+            <a:pPr marL="0" lvl="0" indent="0" algn="l">
+              <a:spcBef>
+                <a:spcPts val="0"/>
+              </a:spcBef>
+              <a:spcAft>
+                <a:spcPts val="0"/>
+              </a:spcAft>
+              <a:buNone/>
+            </a:pPr>
+            <a:r>
+              <a:t/>
+            </a:r>
+            <a:endParaRPr/>
+          </a:p>
+          <a:p xmlns:a="http://schemas.openxmlformats.org/drawingml/2006/main">
+            <a:pPr marL="0" lvl="0" indent="0" algn="l">
+              <a:spcBef>
+                <a:spcPts val="0"/>
+              </a:spcBef>
+              <a:spcAft>
+                <a:spcPts val="0"/>
+              </a:spcAft>
+              <a:buNone/>
+            </a:pPr>
+            <a:r>
+              <a:t>3. If it becomes a union, every member starts at byte 0 and the size is 4 bytes under these assumptions.</a:t>
             </a:r>
             <a:endParaRPr/>
           </a:p>
@@ -2106,7 +2736,97 @@
               <a:buNone/>
             </a:pPr>
             <a:r>
-              <a:t>Answer: Sign = −1. Actual exponent = 129 − 127 = 2. Significand = 1.0101₂ = 1 + 1/4 + 1/16 = 1.3125. Value = −1 × 4 × 1.3125 = −5.25.</a:t>
+              <a:t>Answer: 1. Sign = −1 because the sign bit is 1.</a:t>
+            </a:r>
+            <a:endParaRPr/>
+          </a:p>
+          <a:p xmlns:a="http://schemas.openxmlformats.org/drawingml/2006/main">
+            <a:pPr marL="0" lvl="0" indent="0" algn="l">
+              <a:spcBef>
+                <a:spcPts val="0"/>
+              </a:spcBef>
+              <a:spcAft>
+                <a:spcPts val="0"/>
+              </a:spcAft>
+              <a:buNone/>
+            </a:pPr>
+            <a:r>
+              <a:t/>
+            </a:r>
+            <a:endParaRPr/>
+          </a:p>
+          <a:p xmlns:a="http://schemas.openxmlformats.org/drawingml/2006/main">
+            <a:pPr marL="0" lvl="0" indent="0" algn="l">
+              <a:spcBef>
+                <a:spcPts val="0"/>
+              </a:spcBef>
+              <a:spcAft>
+                <a:spcPts val="0"/>
+              </a:spcAft>
+              <a:buNone/>
+            </a:pPr>
+            <a:r>
+              <a:t>2. Actual exponent = 129 − 127 = 2.</a:t>
+            </a:r>
+            <a:endParaRPr/>
+          </a:p>
+          <a:p xmlns:a="http://schemas.openxmlformats.org/drawingml/2006/main">
+            <a:pPr marL="0" lvl="0" indent="0" algn="l">
+              <a:spcBef>
+                <a:spcPts val="0"/>
+              </a:spcBef>
+              <a:spcAft>
+                <a:spcPts val="0"/>
+              </a:spcAft>
+              <a:buNone/>
+            </a:pPr>
+            <a:r>
+              <a:t/>
+            </a:r>
+            <a:endParaRPr/>
+          </a:p>
+          <a:p xmlns:a="http://schemas.openxmlformats.org/drawingml/2006/main">
+            <a:pPr marL="0" lvl="0" indent="0" algn="l">
+              <a:spcBef>
+                <a:spcPts val="0"/>
+              </a:spcBef>
+              <a:spcAft>
+                <a:spcPts val="0"/>
+              </a:spcAft>
+              <a:buNone/>
+            </a:pPr>
+            <a:r>
+              <a:t>3. Significand = 1.0101₂ = 1 + 1/4 + 1/16 = 1.3125.</a:t>
+            </a:r>
+            <a:endParaRPr/>
+          </a:p>
+          <a:p xmlns:a="http://schemas.openxmlformats.org/drawingml/2006/main">
+            <a:pPr marL="0" lvl="0" indent="0" algn="l">
+              <a:spcBef>
+                <a:spcPts val="0"/>
+              </a:spcBef>
+              <a:spcAft>
+                <a:spcPts val="0"/>
+              </a:spcAft>
+              <a:buNone/>
+            </a:pPr>
+            <a:r>
+              <a:t/>
+            </a:r>
+            <a:endParaRPr/>
+          </a:p>
+          <a:p xmlns:a="http://schemas.openxmlformats.org/drawingml/2006/main">
+            <a:pPr marL="0" lvl="0" indent="0" algn="l">
+              <a:spcBef>
+                <a:spcPts val="0"/>
+              </a:spcBef>
+              <a:spcAft>
+                <a:spcPts val="0"/>
+              </a:spcAft>
+              <a:buNone/>
+            </a:pPr>
+            <a:r>
+              <a:t>4. Decimal value = −1 × 4 × 1.3125 = −5.25.</a:t>
             </a:r>
             <a:endParaRPr/>
           </a:p>
@@ -3990,14 +4710,14 @@
   </p:cSld>
   <p:clrMap bg1="dk1" tx1="lt1" bg2="dk2" tx2="lt2" accent1="accent1" accent2="accent2" accent3="accent3" accent4="accent4" accent5="accent5" accent6="accent6" hlink="hlink" folHlink="folHlink"/>
   <p:sldLayoutIdLst>
-    <p:sldLayoutId xmlns:r="http://schemas.openxmlformats.org/officeDocument/2006/relationships" id="2147483649" r:id="R3ea5262b201a40d3"/>
-    <p:sldLayoutId xmlns:r="http://schemas.openxmlformats.org/officeDocument/2006/relationships" id="2147483650" r:id="R820490739c8d474a"/>
-    <p:sldLayoutId xmlns:r="http://schemas.openxmlformats.org/officeDocument/2006/relationships" id="2147483651" r:id="Rcc0bde5d44a049ef"/>
-    <p:sldLayoutId xmlns:r="http://schemas.openxmlformats.org/officeDocument/2006/relationships" id="2147483652" r:id="R5501ecb2c7b44cc8"/>
-    <p:sldLayoutId xmlns:r="http://schemas.openxmlformats.org/officeDocument/2006/relationships" id="2147483653" r:id="Ra1c1a70821ac4be2"/>
-    <p:sldLayoutId xmlns:r="http://schemas.openxmlformats.org/officeDocument/2006/relationships" id="2147483654" r:id="R90c4f9151f0042ec"/>
-    <p:sldLayoutId xmlns:r="http://schemas.openxmlformats.org/officeDocument/2006/relationships" id="2147483655" r:id="Reb368d11bec74db7"/>
-    <p:sldLayoutId xmlns:r="http://schemas.openxmlformats.org/officeDocument/2006/relationships" id="2147483656" r:id="Rcfabe995655f4406"/>
+    <p:sldLayoutId xmlns:r="http://schemas.openxmlformats.org/officeDocument/2006/relationships" id="2147483649" r:id="Rf53338cf733a490a"/>
+    <p:sldLayoutId xmlns:r="http://schemas.openxmlformats.org/officeDocument/2006/relationships" id="2147483650" r:id="Rcfb49e40bd424e01"/>
+    <p:sldLayoutId xmlns:r="http://schemas.openxmlformats.org/officeDocument/2006/relationships" id="2147483651" r:id="R206094983cc14b3e"/>
+    <p:sldLayoutId xmlns:r="http://schemas.openxmlformats.org/officeDocument/2006/relationships" id="2147483652" r:id="Rbc8be456406049f9"/>
+    <p:sldLayoutId xmlns:r="http://schemas.openxmlformats.org/officeDocument/2006/relationships" id="2147483653" r:id="R88f16ed997764707"/>
+    <p:sldLayoutId xmlns:r="http://schemas.openxmlformats.org/officeDocument/2006/relationships" id="2147483654" r:id="Ra023ef25661a4388"/>
+    <p:sldLayoutId xmlns:r="http://schemas.openxmlformats.org/officeDocument/2006/relationships" id="2147483655" r:id="Re20ed1d658194596"/>
+    <p:sldLayoutId xmlns:r="http://schemas.openxmlformats.org/officeDocument/2006/relationships" id="2147483656" r:id="Rc337f623259748ee"/>
   </p:sldLayoutIdLst>
   <p:hf hdr="0" dt="0"/>
   <p:txStyles>
@@ -6461,7 +7181,7 @@
           <p:cNvPr id="534" name="Takeaway">
             <a:extLst xmlns:a="http://schemas.openxmlformats.org/drawingml/2006/main">
               <a:ext uri="{FF2B5EF4-FFF2-40B4-BE49-F238E27FC236}">
-                <a16:creationId xmlns:a16="http://schemas.microsoft.com/office/drawing/2014/main" id="{7693FAC2-1839-430A-943B-04EEBDFB204B}"/>
+                <a16:creationId xmlns:a16="http://schemas.microsoft.com/office/drawing/2014/main" id="{AEAEA662-56BE-4933-B402-338E393AF37B}"/>
               </a:ext>
             </a:extLst>
           </p:cNvPr>
@@ -7551,7 +8271,7 @@
           <p:cNvPr id="534" name="Takeaway">
             <a:extLst xmlns:a="http://schemas.openxmlformats.org/drawingml/2006/main">
               <a:ext uri="{FF2B5EF4-FFF2-40B4-BE49-F238E27FC236}">
-                <a16:creationId xmlns:a16="http://schemas.microsoft.com/office/drawing/2014/main" id="{5A2441C9-DFC6-4435-8994-9849435ED009}"/>
+                <a16:creationId xmlns:a16="http://schemas.microsoft.com/office/drawing/2014/main" id="{E8C8B9A6-9A97-4EFC-9157-5E7B65239F6F}"/>
               </a:ext>
             </a:extLst>
           </p:cNvPr>
@@ -8690,7 +9410,7 @@
           <p:cNvPr id="534" name="Takeaway">
             <a:extLst xmlns:a="http://schemas.openxmlformats.org/drawingml/2006/main">
               <a:ext uri="{FF2B5EF4-FFF2-40B4-BE49-F238E27FC236}">
-                <a16:creationId xmlns:a16="http://schemas.microsoft.com/office/drawing/2014/main" id="{F4D93A4A-CDB2-496F-A8E5-37D5162F5531}"/>
+                <a16:creationId xmlns:a16="http://schemas.microsoft.com/office/drawing/2014/main" id="{012F7FD1-B715-4B7F-994F-C339EE2677A8}"/>
               </a:ext>
             </a:extLst>
           </p:cNvPr>
@@ -9796,7 +10516,7 @@
           <p:cNvPr id="534" name="Takeaway">
             <a:extLst xmlns:a="http://schemas.openxmlformats.org/drawingml/2006/main">
               <a:ext uri="{FF2B5EF4-FFF2-40B4-BE49-F238E27FC236}">
-                <a16:creationId xmlns:a16="http://schemas.microsoft.com/office/drawing/2014/main" id="{5E2AF9FC-C910-48F9-B1EB-4B01C3498123}"/>
+                <a16:creationId xmlns:a16="http://schemas.microsoft.com/office/drawing/2014/main" id="{69C5629F-9CEC-4E04-A62F-A90FAB491945}"/>
               </a:ext>
             </a:extLst>
           </p:cNvPr>
@@ -10869,7 +11589,7 @@
           <p:cNvPr id="534" name="Takeaway">
             <a:extLst xmlns:a="http://schemas.openxmlformats.org/drawingml/2006/main">
               <a:ext uri="{FF2B5EF4-FFF2-40B4-BE49-F238E27FC236}">
-                <a16:creationId xmlns:a16="http://schemas.microsoft.com/office/drawing/2014/main" id="{59A79DE3-4F7C-4576-9CD3-7BD0D1E42D13}"/>
+                <a16:creationId xmlns:a16="http://schemas.microsoft.com/office/drawing/2014/main" id="{712A850F-E2D7-4EA8-AD7E-970A047A6A31}"/>
               </a:ext>
             </a:extLst>
           </p:cNvPr>
@@ -11926,7 +12646,7 @@
           <p:cNvPr id="534" name="Takeaway">
             <a:extLst xmlns:a="http://schemas.openxmlformats.org/drawingml/2006/main">
               <a:ext uri="{FF2B5EF4-FFF2-40B4-BE49-F238E27FC236}">
-                <a16:creationId xmlns:a16="http://schemas.microsoft.com/office/drawing/2014/main" id="{B9BF8A70-AFA0-43D3-8C22-3B75F53BA2F0}"/>
+                <a16:creationId xmlns:a16="http://schemas.microsoft.com/office/drawing/2014/main" id="{B53D8CB3-427F-46CD-ADBD-59287A96FF28}"/>
               </a:ext>
             </a:extLst>
           </p:cNvPr>
@@ -13048,7 +13768,7 @@
           <p:cNvPr id="534" name="Takeaway">
             <a:extLst xmlns:a="http://schemas.openxmlformats.org/drawingml/2006/main">
               <a:ext uri="{FF2B5EF4-FFF2-40B4-BE49-F238E27FC236}">
-                <a16:creationId xmlns:a16="http://schemas.microsoft.com/office/drawing/2014/main" id="{DA15B0E1-54A2-4897-9536-91DC99766AF6}"/>
+                <a16:creationId xmlns:a16="http://schemas.microsoft.com/office/drawing/2014/main" id="{FB79E5B0-37D0-4DEB-A781-A77B02ECCAB6}"/>
               </a:ext>
             </a:extLst>
           </p:cNvPr>
@@ -14089,7 +14809,7 @@
           <p:cNvPr id="534" name="Takeaway">
             <a:extLst xmlns:a="http://schemas.openxmlformats.org/drawingml/2006/main">
               <a:ext uri="{FF2B5EF4-FFF2-40B4-BE49-F238E27FC236}">
-                <a16:creationId xmlns:a16="http://schemas.microsoft.com/office/drawing/2014/main" id="{D7C2DE69-4932-42C5-91C7-751C639ED8F4}"/>
+                <a16:creationId xmlns:a16="http://schemas.microsoft.com/office/drawing/2014/main" id="{B215726E-FBDF-40CA-A84F-BA69C39E1E5A}"/>
               </a:ext>
             </a:extLst>
           </p:cNvPr>
@@ -15130,7 +15850,7 @@
           <p:cNvPr id="534" name="Takeaway">
             <a:extLst xmlns:a="http://schemas.openxmlformats.org/drawingml/2006/main">
               <a:ext uri="{FF2B5EF4-FFF2-40B4-BE49-F238E27FC236}">
-                <a16:creationId xmlns:a16="http://schemas.microsoft.com/office/drawing/2014/main" id="{8E3E9056-1F73-484F-ABD8-BF85C973F717}"/>
+                <a16:creationId xmlns:a16="http://schemas.microsoft.com/office/drawing/2014/main" id="{DA833D5B-D4E5-40BA-9784-E5FCE6663962}"/>
               </a:ext>
             </a:extLst>
           </p:cNvPr>
@@ -16203,7 +16923,7 @@
           <p:cNvPr id="534" name="Takeaway">
             <a:extLst xmlns:a="http://schemas.openxmlformats.org/drawingml/2006/main">
               <a:ext uri="{FF2B5EF4-FFF2-40B4-BE49-F238E27FC236}">
-                <a16:creationId xmlns:a16="http://schemas.microsoft.com/office/drawing/2014/main" id="{4B9F37F3-21E5-4626-BE1A-BF6CC9E9967C}"/>
+                <a16:creationId xmlns:a16="http://schemas.microsoft.com/office/drawing/2014/main" id="{02C498B6-842B-40BA-8AA0-35EFF8740749}"/>
               </a:ext>
             </a:extLst>
           </p:cNvPr>
@@ -17375,7 +18095,7 @@
           <p:cNvPr id="534" name="Takeaway">
             <a:extLst xmlns:a="http://schemas.openxmlformats.org/drawingml/2006/main">
               <a:ext uri="{FF2B5EF4-FFF2-40B4-BE49-F238E27FC236}">
-                <a16:creationId xmlns:a16="http://schemas.microsoft.com/office/drawing/2014/main" id="{9C9936D5-9ACB-4BE4-806F-42513E25DD25}"/>
+                <a16:creationId xmlns:a16="http://schemas.microsoft.com/office/drawing/2014/main" id="{68E20030-1846-4ED5-B9C0-B90690864AF8}"/>
               </a:ext>
             </a:extLst>
           </p:cNvPr>
@@ -18432,7 +19152,7 @@
           <p:cNvPr id="534" name="Takeaway">
             <a:extLst xmlns:a="http://schemas.openxmlformats.org/drawingml/2006/main">
               <a:ext uri="{FF2B5EF4-FFF2-40B4-BE49-F238E27FC236}">
-                <a16:creationId xmlns:a16="http://schemas.microsoft.com/office/drawing/2014/main" id="{53DF57CF-9F9F-4CCA-9C91-107DDE6F6BB5}"/>
+                <a16:creationId xmlns:a16="http://schemas.microsoft.com/office/drawing/2014/main" id="{5DA747E1-1BE7-4BC2-9547-9A3DA7C84826}"/>
               </a:ext>
             </a:extLst>
           </p:cNvPr>
@@ -19654,7 +20374,7 @@
           <p:cNvPr id="534" name="Takeaway">
             <a:extLst xmlns:a="http://schemas.openxmlformats.org/drawingml/2006/main">
               <a:ext uri="{FF2B5EF4-FFF2-40B4-BE49-F238E27FC236}">
-                <a16:creationId xmlns:a16="http://schemas.microsoft.com/office/drawing/2014/main" id="{439C6092-D029-4C32-B071-3C7811883F7A}"/>
+                <a16:creationId xmlns:a16="http://schemas.microsoft.com/office/drawing/2014/main" id="{AB2EC032-742F-4FF6-BA79-A483D3CB49F8}"/>
               </a:ext>
             </a:extLst>
           </p:cNvPr>
@@ -20826,7 +21546,7 @@
           <p:cNvPr id="534" name="Takeaway">
             <a:extLst xmlns:a="http://schemas.openxmlformats.org/drawingml/2006/main">
               <a:ext uri="{FF2B5EF4-FFF2-40B4-BE49-F238E27FC236}">
-                <a16:creationId xmlns:a16="http://schemas.microsoft.com/office/drawing/2014/main" id="{15E44B3F-CCB6-40F6-900F-846619C4DA4C}"/>
+                <a16:creationId xmlns:a16="http://schemas.microsoft.com/office/drawing/2014/main" id="{7477D5A0-C27B-4A09-8565-AE4BE857AA09}"/>
               </a:ext>
             </a:extLst>
           </p:cNvPr>
@@ -21933,7 +22653,7 @@
           <p:cNvPr id="534" name="Takeaway">
             <a:extLst xmlns:a="http://schemas.openxmlformats.org/drawingml/2006/main">
               <a:ext uri="{FF2B5EF4-FFF2-40B4-BE49-F238E27FC236}">
-                <a16:creationId xmlns:a16="http://schemas.microsoft.com/office/drawing/2014/main" id="{F2F70765-EDF8-43D5-A41C-E276583BE2AD}"/>
+                <a16:creationId xmlns:a16="http://schemas.microsoft.com/office/drawing/2014/main" id="{715619E1-0271-46A4-A0B6-E88BF43EEA72}"/>
               </a:ext>
             </a:extLst>
           </p:cNvPr>
@@ -23039,7 +23759,7 @@
           <p:cNvPr id="534" name="Takeaway">
             <a:extLst xmlns:a="http://schemas.openxmlformats.org/drawingml/2006/main">
               <a:ext uri="{FF2B5EF4-FFF2-40B4-BE49-F238E27FC236}">
-                <a16:creationId xmlns:a16="http://schemas.microsoft.com/office/drawing/2014/main" id="{17A9F809-9A02-44B6-9949-30872F025B35}"/>
+                <a16:creationId xmlns:a16="http://schemas.microsoft.com/office/drawing/2014/main" id="{032C0083-D447-4B58-A063-E59717330DEC}"/>
               </a:ext>
             </a:extLst>
           </p:cNvPr>

</xml_diff>